<commit_message>
add alt-text to images
</commit_message>
<xml_diff>
--- a/modules/week01/eds-213_intro.pptx
+++ b/modules/week01/eds-213_intro.pptx
@@ -7565,7 +7565,7 @@
       </p:grpSpPr>
       <p:pic>
         <p:nvPicPr>
-          <p:cNvPr id="92" name="Google Shape;92;p26"/>
+          <p:cNvPr id="92" name="Google Shape;92;p26" descr="Greg’s picture - Instructor"/>
           <p:cNvPicPr preferRelativeResize="0"/>
           <p:nvPr/>
         </p:nvPicPr>
@@ -7670,7 +7670,7 @@
       </p:sp>
       <p:pic>
         <p:nvPicPr>
-          <p:cNvPr id="94" name="Google Shape;94;p26"/>
+          <p:cNvPr id="94" name="Google Shape;94;p26" descr="Julien’s picture - Instructor"/>
           <p:cNvPicPr preferRelativeResize="0"/>
           <p:nvPr/>
         </p:nvPicPr>
@@ -7776,7 +7776,7 @@
       </p:sp>
       <p:pic>
         <p:nvPicPr>
-          <p:cNvPr id="96" name="Google Shape;96;p26"/>
+          <p:cNvPr id="96" name="Google Shape;96;p26" descr="Renata’s picture - Instructor"/>
           <p:cNvPicPr preferRelativeResize="0"/>
           <p:nvPr/>
         </p:nvPicPr>

</xml_diff>